<commit_message>
Update midterm deck with post-build revisions
Captures the October 14 rebuild of the exported deck so the working
tree is clean before moving to the yield-stratification work.

Co-Authored-By: Claude Opus 5 <noreply@anthropic.com>
</commit_message>
<xml_diff>
--- a/presentation/mid-semester/output/Midterm Presentation.pptx
+++ b/presentation/mid-semester/output/Midterm Presentation.pptx
@@ -115,6 +115,11 @@
       </a:defRPr>
     </a:lvl9pPr>
   </p:defaultTextStyle>
+  <p:extLst>
+    <p:ext uri="{EFAFB233-063F-42B5-8137-9DF3F51BA10A}">
+      <p15:sldGuideLst xmlns:p15="http://schemas.microsoft.com/office/powerpoint/2012/main"/>
+    </p:ext>
+  </p:extLst>
 </p:presentation>
 </file>
 
@@ -4139,79 +4144,6 @@
       </p:sp>
       <p:sp>
         <p:nvSpPr>
-          <p:cNvPr id="3" name="Rectangle 2">
-            <a:extLst>
-              <a:ext uri="{FF2B5EF4-FFF2-40B4-BE49-F238E27FC236}">
-                <a16:creationId xmlns:a16="http://schemas.microsoft.com/office/drawing/2014/main" id="{F4595944-3259-4657-B541-DF5F7E1D6D4D}"/>
-              </a:ext>
-            </a:extLst>
-          </p:cNvPr>
-          <p:cNvSpPr>
-            <a:spLocks noGrp="1"/>
-          </p:cNvSpPr>
-          <p:nvPr/>
-        </p:nvSpPr>
-        <p:spPr>
-          <a:xfrm>
-            <a:off x="552450" y="3733800"/>
-            <a:ext cx="6953250" cy="781050"/>
-          </a:xfrm>
-          <a:prstGeom prst="rect">
-            <a:avLst/>
-          </a:prstGeom>
-          <a:noFill/>
-          <a:ln w="0">
-            <a:noFill/>
-            <a:prstDash val="solid"/>
-          </a:ln>
-        </p:spPr>
-        <p:txBody>
-          <a:bodyPr lIns="0" tIns="0" rIns="0" bIns="0" anchor="ctr">
-            <a:noAutofit/>
-          </a:bodyPr>
-          <a:lstStyle>
-            <a:defPPr algn="l">
-              <a:defRPr sz="2175" b="0" i="0">
-                <a:solidFill>
-                  <a:srgbClr val="BFD3C8"/>
-                </a:solidFill>
-                <a:latin typeface="Arial"/>
-                <a:ea typeface="Arial"/>
-                <a:cs typeface="Arial"/>
-              </a:defRPr>
-            </a:defPPr>
-          </a:lstStyle>
-          <a:p>
-            <a:pPr algn="l">
-              <a:lnSpc>
-                <a:spcPct val="100000"/>
-              </a:lnSpc>
-              <a:buNone/>
-              <a:defRPr sz="2175" b="0" i="0">
-                <a:solidFill>
-                  <a:srgbClr val="BFD3C8"/>
-                </a:solidFill>
-                <a:latin typeface="Arial"/>
-                <a:ea typeface="Arial"/>
-                <a:cs typeface="Arial"/>
-              </a:defRPr>
-            </a:pPr>
-            <a:r>
-              <a:rPr sz="2175" b="0" i="0">
-                <a:solidFill>
-                  <a:srgbClr val="BFD3C8"/>
-                </a:solidFill>
-                <a:latin typeface="Arial"/>
-                <a:ea typeface="Arial"/>
-                <a:cs typeface="Arial"/>
-              </a:rPr>
-              <a:t>The physical-risk model works. The trading signal did not.</a:t>
-            </a:r>
-          </a:p>
-        </p:txBody>
-      </p:sp>
-      <p:sp>
-        <p:nvSpPr>
           <p:cNvPr id="4" name="Rectangle 3">
             <a:extLst>
               <a:ext uri="{FF2B5EF4-FFF2-40B4-BE49-F238E27FC236}">
@@ -15648,79 +15580,6 @@
                 <a:cs typeface="Georgia"/>
               </a:rPr>
               <a:t>Questions?</a:t>
-            </a:r>
-          </a:p>
-        </p:txBody>
-      </p:sp>
-      <p:sp>
-        <p:nvSpPr>
-          <p:cNvPr id="14" name="Rectangle 13">
-            <a:extLst>
-              <a:ext uri="{FF2B5EF4-FFF2-40B4-BE49-F238E27FC236}">
-                <a16:creationId xmlns:a16="http://schemas.microsoft.com/office/drawing/2014/main" id="{2B0992A3-D560-4F43-87A3-423708C7B593}"/>
-              </a:ext>
-            </a:extLst>
-          </p:cNvPr>
-          <p:cNvSpPr>
-            <a:spLocks noGrp="1"/>
-          </p:cNvSpPr>
-          <p:nvPr/>
-        </p:nvSpPr>
-        <p:spPr>
-          <a:xfrm>
-            <a:off x="552450" y="5619750"/>
-            <a:ext cx="2857500" cy="342900"/>
-          </a:xfrm>
-          <a:prstGeom prst="rect">
-            <a:avLst/>
-          </a:prstGeom>
-          <a:noFill/>
-          <a:ln w="0">
-            <a:noFill/>
-            <a:prstDash val="solid"/>
-          </a:ln>
-        </p:spPr>
-        <p:txBody>
-          <a:bodyPr lIns="0" tIns="0" rIns="0" bIns="0" anchor="t">
-            <a:noAutofit/>
-          </a:bodyPr>
-          <a:lstStyle>
-            <a:defPPr algn="l">
-              <a:defRPr sz="1500" b="0" i="0">
-                <a:solidFill>
-                  <a:srgbClr val="BFD3C8"/>
-                </a:solidFill>
-                <a:latin typeface="Arial"/>
-                <a:ea typeface="Arial"/>
-                <a:cs typeface="Arial"/>
-              </a:defRPr>
-            </a:defPPr>
-          </a:lstStyle>
-          <a:p>
-            <a:pPr algn="l">
-              <a:lnSpc>
-                <a:spcPct val="100000"/>
-              </a:lnSpc>
-              <a:buNone/>
-              <a:defRPr sz="1500" b="0" i="0">
-                <a:solidFill>
-                  <a:srgbClr val="BFD3C8"/>
-                </a:solidFill>
-                <a:latin typeface="Arial"/>
-                <a:ea typeface="Arial"/>
-                <a:cs typeface="Arial"/>
-              </a:defRPr>
-            </a:pPr>
-            <a:r>
-              <a:rPr sz="1500" b="0" i="0">
-                <a:solidFill>
-                  <a:srgbClr val="BFD3C8"/>
-                </a:solidFill>
-                <a:latin typeface="Arial"/>
-                <a:ea typeface="Arial"/>
-                <a:cs typeface="Arial"/>
-              </a:rPr>
-              <a:t>3 minutes</a:t>
             </a:r>
           </a:p>
         </p:txBody>

</xml_diff>